<commit_message>
removed custom slide shows
</commit_message>
<xml_diff>
--- a/flask_app/assets/base.slides.pptx
+++ b/flask_app/assets/base.slides.pptx
@@ -9,17 +9,6 @@
   </p:notesMasterIdLst>
   <p:sldSz cx="12192000" cy="6858000"/>
   <p:notesSz cx="6858000" cy="9144000"/>
-  <p:custShowLst>
-    <p:custShow name="Diaporama standard GP" id="0">
-      <p:sldLst/>
-    </p:custShow>
-    <p:custShow name="Mini-diaporama post-conférence (pour affichage en boucle)" id="1">
-      <p:sldLst/>
-    </p:custShow>
-    <p:custShow name="Diaporama pour export PDF (taille minimale + inclure les diapos cachées en sélectionnant ce diaporama personnalisé !)" id="2">
-      <p:sldLst/>
-    </p:custShow>
-  </p:custShowLst>
   <p:defaultTextStyle>
     <a:defPPr>
       <a:defRPr lang="fr-FR"/>
@@ -217,7 +206,7 @@
           <a:p>
             <a:fld id="{C8E227CC-8F40-43A0-A784-1E77C9226FBC}" type="datetimeFigureOut">
               <a:rPr lang="fr-FR" smtClean="0"/>
-              <a:t>11/05/2025</a:t>
+              <a:t>15/05/2025</a:t>
             </a:fld>
             <a:endParaRPr lang="fr-FR"/>
           </a:p>
@@ -375,7 +364,7 @@
           <a:p>
             <a:fld id="{A6F4D65A-1715-468F-B794-3B7668D934DA}" type="slidenum">
               <a:rPr lang="fr-FR" smtClean="0"/>
-              <a:t>‹#›</a:t>
+              <a:t>‹N°›</a:t>
             </a:fld>
             <a:endParaRPr lang="fr-FR"/>
           </a:p>
@@ -657,7 +646,7 @@
             <a:fld id="{00E0E155-A4C6-4C24-B5DD-AE65EC126F8C}" type="slidenum">
               <a:rPr lang="fr-FR" smtClean="0"/>
               <a:pPr/>
-              <a:t>‹#›</a:t>
+              <a:t>‹N°›</a:t>
             </a:fld>
             <a:endParaRPr lang="fr-FR" dirty="0"/>
           </a:p>
@@ -904,7 +893,7 @@
             <a:fld id="{00E0E155-A4C6-4C24-B5DD-AE65EC126F8C}" type="slidenum">
               <a:rPr lang="fr-FR" smtClean="0"/>
               <a:pPr/>
-              <a:t>‹#›</a:t>
+              <a:t>‹N°›</a:t>
             </a:fld>
             <a:endParaRPr lang="fr-FR" dirty="0"/>
           </a:p>
@@ -1152,7 +1141,7 @@
             <a:fld id="{00E0E155-A4C6-4C24-B5DD-AE65EC126F8C}" type="slidenum">
               <a:rPr lang="fr-FR" smtClean="0"/>
               <a:pPr/>
-              <a:t>‹#›</a:t>
+              <a:t>‹N°›</a:t>
             </a:fld>
             <a:endParaRPr lang="fr-FR" dirty="0"/>
           </a:p>
@@ -1398,7 +1387,7 @@
             <a:fld id="{00E0E155-A4C6-4C24-B5DD-AE65EC126F8C}" type="slidenum">
               <a:rPr lang="fr-FR" smtClean="0"/>
               <a:pPr/>
-              <a:t>‹#›</a:t>
+              <a:t>‹N°›</a:t>
             </a:fld>
             <a:endParaRPr lang="fr-FR" dirty="0"/>
           </a:p>
@@ -1662,7 +1651,7 @@
             <a:fld id="{00E0E155-A4C6-4C24-B5DD-AE65EC126F8C}" type="slidenum">
               <a:rPr lang="fr-FR" smtClean="0"/>
               <a:pPr/>
-              <a:t>‹#›</a:t>
+              <a:t>‹N°›</a:t>
             </a:fld>
             <a:endParaRPr lang="fr-FR" dirty="0"/>
           </a:p>
@@ -1926,7 +1915,7 @@
             <a:fld id="{00E0E155-A4C6-4C24-B5DD-AE65EC126F8C}" type="slidenum">
               <a:rPr lang="fr-FR" smtClean="0"/>
               <a:pPr/>
-              <a:t>‹#›</a:t>
+              <a:t>‹N°›</a:t>
             </a:fld>
             <a:endParaRPr lang="fr-FR" dirty="0"/>
           </a:p>

</xml_diff>